<commit_message>
Update model notebook (new schematic, iterations)
</commit_message>
<xml_diff>
--- a/notebooks/Model_varying_mixing/Schematic.pptx
+++ b/notebooks/Model_varying_mixing/Schematic.pptx
@@ -131,7 +131,7 @@
 <file path=ppt/revisionInfo.xml><?xml version="1.0" encoding="utf-8"?>
 <p1510:revInfo xmlns:a="http://schemas.openxmlformats.org/drawingml/2006/main" xmlns:r="http://schemas.openxmlformats.org/officeDocument/2006/relationships" xmlns:p1510="http://schemas.microsoft.com/office/powerpoint/2015/10/main">
   <p1510:revLst>
-    <p1510:client id="{F9FD2602-ACE2-404E-B12E-A4182221B4C9}" v="315" dt="2026-08-06T09:25:08.951"/>
+    <p1510:client id="{F9FD2602-ACE2-404E-B12E-A4182221B4C9}" v="333" dt="2026-08-06T14:29:43.674"/>
   </p1510:revLst>
 </p1510:revInfo>
 </file>
@@ -141,12 +141,12 @@
   <pc:docChgLst>
     <pc:chgData name="Tomy Doda" userId="023a5e24-f089-4e82-9406-b78528d4275d" providerId="ADAL" clId="{46B57ECA-90EE-4DEE-B7FC-CF6B2BB407ED}"/>
     <pc:docChg chg="modSld">
-      <pc:chgData name="Tomy Doda" userId="023a5e24-f089-4e82-9406-b78528d4275d" providerId="ADAL" clId="{46B57ECA-90EE-4DEE-B7FC-CF6B2BB407ED}" dt="2026-08-06T09:25:08.951" v="314" actId="165"/>
+      <pc:chgData name="Tomy Doda" userId="023a5e24-f089-4e82-9406-b78528d4275d" providerId="ADAL" clId="{46B57ECA-90EE-4DEE-B7FC-CF6B2BB407ED}" dt="2026-08-06T14:29:52.385" v="334" actId="1076"/>
       <pc:docMkLst>
         <pc:docMk/>
       </pc:docMkLst>
-      <pc:sldChg chg="delSp modSp">
-        <pc:chgData name="Tomy Doda" userId="023a5e24-f089-4e82-9406-b78528d4275d" providerId="ADAL" clId="{46B57ECA-90EE-4DEE-B7FC-CF6B2BB407ED}" dt="2026-08-06T09:25:08.951" v="314" actId="165"/>
+      <pc:sldChg chg="delSp modSp mod">
+        <pc:chgData name="Tomy Doda" userId="023a5e24-f089-4e82-9406-b78528d4275d" providerId="ADAL" clId="{46B57ECA-90EE-4DEE-B7FC-CF6B2BB407ED}" dt="2026-08-06T14:29:52.385" v="334" actId="1076"/>
         <pc:sldMkLst>
           <pc:docMk/>
           <pc:sldMk cId="983911713" sldId="421"/>
@@ -208,7 +208,7 @@
           </ac:spMkLst>
         </pc:spChg>
         <pc:spChg chg="mod">
-          <ac:chgData name="Tomy Doda" userId="023a5e24-f089-4e82-9406-b78528d4275d" providerId="ADAL" clId="{46B57ECA-90EE-4DEE-B7FC-CF6B2BB407ED}" dt="2026-08-06T09:23:58.527" v="311" actId="255"/>
+          <ac:chgData name="Tomy Doda" userId="023a5e24-f089-4e82-9406-b78528d4275d" providerId="ADAL" clId="{46B57ECA-90EE-4DEE-B7FC-CF6B2BB407ED}" dt="2026-08-06T14:29:52.385" v="334" actId="1076"/>
           <ac:spMkLst>
             <pc:docMk/>
             <pc:sldMk cId="983911713" sldId="421"/>
@@ -7175,8 +7175,8 @@
           </a:p>
         </p:txBody>
       </p:sp>
-      <mc:AlternateContent xmlns:mc="http://schemas.openxmlformats.org/markup-compatibility/2006">
-        <mc:Choice xmlns:a14="http://schemas.microsoft.com/office/drawing/2010/main" Requires="a14">
+      <mc:AlternateContent xmlns:mc="http://schemas.openxmlformats.org/markup-compatibility/2006" xmlns:a14="http://schemas.microsoft.com/office/drawing/2010/main">
+        <mc:Choice Requires="a14">
           <p:sp>
             <p:nvSpPr>
               <p:cNvPr id="16" name="TextBox 15">
@@ -7355,7 +7355,7 @@
             </p:txBody>
           </p:sp>
         </mc:Choice>
-        <mc:Fallback>
+        <mc:Fallback xmlns="">
           <p:sp>
             <p:nvSpPr>
               <p:cNvPr id="16" name="TextBox 15">
@@ -7416,8 +7416,8 @@
             </p:nvSpPr>
             <p:spPr>
               <a:xfrm>
-                <a:off x="-428812" y="467296"/>
-                <a:ext cx="1970363" cy="423770"/>
+                <a:off x="753759" y="570475"/>
+                <a:ext cx="2950570" cy="423770"/>
               </a:xfrm>
               <a:prstGeom prst="rect">
                 <a:avLst/>
@@ -7437,17 +7437,59 @@
                       <m:jc m:val="centerGroup"/>
                     </m:oMathParaPr>
                     <m:oMath xmlns:m="http://schemas.openxmlformats.org/officeDocument/2006/math">
+                      <m:sSub>
+                        <m:sSubPr>
+                          <m:ctrlPr>
+                            <a:rPr lang="fr-CH" sz="2000" b="0" i="1" smtClean="0">
+                              <a:latin typeface="Cambria Math" panose="02040503050406030204" pitchFamily="18" charset="0"/>
+                            </a:rPr>
+                          </m:ctrlPr>
+                        </m:sSubPr>
+                        <m:e>
+                          <m:r>
+                            <a:rPr lang="fr-CH" sz="2000" b="0" i="1" smtClean="0">
+                              <a:latin typeface="Cambria Math" panose="02040503050406030204" pitchFamily="18" charset="0"/>
+                            </a:rPr>
+                            <m:t>𝑀</m:t>
+                          </m:r>
+                        </m:e>
+                        <m:sub>
+                          <m:r>
+                            <a:rPr lang="fr-CH" sz="2000" b="0" i="1" smtClean="0">
+                              <a:latin typeface="Cambria Math" panose="02040503050406030204" pitchFamily="18" charset="0"/>
+                            </a:rPr>
+                            <m:t>𝑜𝑢𝑡</m:t>
+                          </m:r>
+                        </m:sub>
+                      </m:sSub>
+                      <m:d>
+                        <m:dPr>
+                          <m:ctrlPr>
+                            <a:rPr lang="fr-CH" sz="2000" b="0" i="1" smtClean="0">
+                              <a:latin typeface="Cambria Math" panose="02040503050406030204" pitchFamily="18" charset="0"/>
+                            </a:rPr>
+                          </m:ctrlPr>
+                        </m:dPr>
+                        <m:e>
+                          <m:r>
+                            <a:rPr lang="fr-CH" sz="2000" b="0" i="1" smtClean="0">
+                              <a:latin typeface="Cambria Math" panose="02040503050406030204" pitchFamily="18" charset="0"/>
+                            </a:rPr>
+                            <m:t>𝑡</m:t>
+                          </m:r>
+                        </m:e>
+                      </m:d>
+                      <m:r>
+                        <a:rPr lang="fr-CH" sz="2000" b="0" i="1" smtClean="0">
+                          <a:latin typeface="Cambria Math" panose="02040503050406030204" pitchFamily="18" charset="0"/>
+                        </a:rPr>
+                        <m:t>=</m:t>
+                      </m:r>
                       <m:r>
                         <a:rPr lang="fr-CH" sz="2000" b="0" i="1" smtClean="0">
                           <a:latin typeface="Cambria Math" panose="02040503050406030204" pitchFamily="18" charset="0"/>
                         </a:rPr>
                         <m:t>𝑄</m:t>
-                      </m:r>
-                      <m:r>
-                        <a:rPr lang="fr-CH" sz="2000" b="0" i="1" smtClean="0">
-                          <a:latin typeface="Cambria Math" panose="02040503050406030204" pitchFamily="18" charset="0"/>
-                        </a:rPr>
-                        <m:t>, </m:t>
                       </m:r>
                       <m:sSub>
                         <m:sSubPr>
@@ -7517,8 +7559,8 @@
             </p:nvSpPr>
             <p:spPr>
               <a:xfrm>
-                <a:off x="-428812" y="467296"/>
-                <a:ext cx="1970363" cy="423770"/>
+                <a:off x="753759" y="570475"/>
+                <a:ext cx="2950570" cy="423770"/>
               </a:xfrm>
               <a:prstGeom prst="rect">
                 <a:avLst/>
@@ -7545,8 +7587,8 @@
           </p:sp>
         </mc:Fallback>
       </mc:AlternateContent>
-      <mc:AlternateContent xmlns:mc="http://schemas.openxmlformats.org/markup-compatibility/2006">
-        <mc:Choice xmlns:a14="http://schemas.microsoft.com/office/drawing/2010/main" Requires="a14">
+      <mc:AlternateContent xmlns:mc="http://schemas.openxmlformats.org/markup-compatibility/2006" xmlns:a14="http://schemas.microsoft.com/office/drawing/2010/main">
+        <mc:Choice Requires="a14">
           <p:sp>
             <p:nvSpPr>
               <p:cNvPr id="19" name="TextBox 18">
@@ -7632,7 +7674,7 @@
             </p:txBody>
           </p:sp>
         </mc:Choice>
-        <mc:Fallback>
+        <mc:Fallback xmlns="">
           <p:sp>
             <p:nvSpPr>
               <p:cNvPr id="19" name="TextBox 18">
@@ -7677,8 +7719,8 @@
           </p:sp>
         </mc:Fallback>
       </mc:AlternateContent>
-      <mc:AlternateContent xmlns:mc="http://schemas.openxmlformats.org/markup-compatibility/2006">
-        <mc:Choice xmlns:a14="http://schemas.microsoft.com/office/drawing/2010/main" Requires="a14">
+      <mc:AlternateContent xmlns:mc="http://schemas.openxmlformats.org/markup-compatibility/2006" xmlns:a14="http://schemas.microsoft.com/office/drawing/2010/main">
+        <mc:Choice Requires="a14">
           <p:sp>
             <p:nvSpPr>
               <p:cNvPr id="20" name="TextBox 19">
@@ -7764,7 +7806,7 @@
             </p:txBody>
           </p:sp>
         </mc:Choice>
-        <mc:Fallback>
+        <mc:Fallback xmlns="">
           <p:sp>
             <p:nvSpPr>
               <p:cNvPr id="20" name="TextBox 19">
@@ -7851,8 +7893,8 @@
           </a:fontRef>
         </p:style>
       </p:cxnSp>
-      <mc:AlternateContent xmlns:mc="http://schemas.openxmlformats.org/markup-compatibility/2006">
-        <mc:Choice xmlns:a14="http://schemas.microsoft.com/office/drawing/2010/main" Requires="a14">
+      <mc:AlternateContent xmlns:mc="http://schemas.openxmlformats.org/markup-compatibility/2006" xmlns:a14="http://schemas.microsoft.com/office/drawing/2010/main">
+        <mc:Choice Requires="a14">
           <p:sp>
             <p:nvSpPr>
               <p:cNvPr id="22" name="TextBox 21">
@@ -7939,7 +7981,7 @@
             </p:txBody>
           </p:sp>
         </mc:Choice>
-        <mc:Fallback>
+        <mc:Fallback xmlns="">
           <p:sp>
             <p:nvSpPr>
               <p:cNvPr id="22" name="TextBox 21">
@@ -8030,8 +8072,8 @@
           </a:p>
         </p:txBody>
       </p:sp>
-      <mc:AlternateContent xmlns:mc="http://schemas.openxmlformats.org/markup-compatibility/2006">
-        <mc:Choice xmlns:a14="http://schemas.microsoft.com/office/drawing/2010/main" Requires="a14">
+      <mc:AlternateContent xmlns:mc="http://schemas.openxmlformats.org/markup-compatibility/2006" xmlns:a14="http://schemas.microsoft.com/office/drawing/2010/main">
+        <mc:Choice Requires="a14">
           <p:sp>
             <p:nvSpPr>
               <p:cNvPr id="28" name="TextBox 27">
@@ -8233,7 +8275,7 @@
             </p:txBody>
           </p:sp>
         </mc:Choice>
-        <mc:Fallback>
+        <mc:Fallback xmlns="">
           <p:sp>
             <p:nvSpPr>
               <p:cNvPr id="28" name="TextBox 27">
@@ -8332,8 +8374,8 @@
           </a:p>
         </p:txBody>
       </p:sp>
-      <mc:AlternateContent xmlns:mc="http://schemas.openxmlformats.org/markup-compatibility/2006">
-        <mc:Choice xmlns:a14="http://schemas.microsoft.com/office/drawing/2010/main" Requires="a14">
+      <mc:AlternateContent xmlns:mc="http://schemas.openxmlformats.org/markup-compatibility/2006" xmlns:a14="http://schemas.microsoft.com/office/drawing/2010/main">
+        <mc:Choice Requires="a14">
           <p:sp>
             <p:nvSpPr>
               <p:cNvPr id="32" name="TextBox 31">
@@ -8565,7 +8607,7 @@
             </p:txBody>
           </p:sp>
         </mc:Choice>
-        <mc:Fallback>
+        <mc:Fallback xmlns="">
           <p:sp>
             <p:nvSpPr>
               <p:cNvPr id="32" name="TextBox 31">
@@ -8610,8 +8652,8 @@
           </p:sp>
         </mc:Fallback>
       </mc:AlternateContent>
-      <mc:AlternateContent xmlns:mc="http://schemas.openxmlformats.org/markup-compatibility/2006">
-        <mc:Choice xmlns:a14="http://schemas.microsoft.com/office/drawing/2010/main" Requires="a14">
+      <mc:AlternateContent xmlns:mc="http://schemas.openxmlformats.org/markup-compatibility/2006" xmlns:a14="http://schemas.microsoft.com/office/drawing/2010/main">
+        <mc:Choice Requires="a14">
           <p:sp>
             <p:nvSpPr>
               <p:cNvPr id="34" name="TextBox 33">
@@ -9230,7 +9272,7 @@
             </p:txBody>
           </p:sp>
         </mc:Choice>
-        <mc:Fallback>
+        <mc:Fallback xmlns="">
           <p:sp>
             <p:nvSpPr>
               <p:cNvPr id="34" name="TextBox 33">
@@ -9275,8 +9317,8 @@
           </p:sp>
         </mc:Fallback>
       </mc:AlternateContent>
-      <mc:AlternateContent xmlns:mc="http://schemas.openxmlformats.org/markup-compatibility/2006">
-        <mc:Choice xmlns:a14="http://schemas.microsoft.com/office/drawing/2010/main" Requires="a14">
+      <mc:AlternateContent xmlns:mc="http://schemas.openxmlformats.org/markup-compatibility/2006" xmlns:a14="http://schemas.microsoft.com/office/drawing/2010/main">
+        <mc:Choice Requires="a14">
           <p:sp>
             <p:nvSpPr>
               <p:cNvPr id="36" name="TextBox 35">
@@ -9496,7 +9538,7 @@
             </p:txBody>
           </p:sp>
         </mc:Choice>
-        <mc:Fallback>
+        <mc:Fallback xmlns="">
           <p:sp>
             <p:nvSpPr>
               <p:cNvPr id="36" name="TextBox 35">

</xml_diff>